<commit_message>
Working on lecture 09
</commit_message>
<xml_diff>
--- a/slides/lecture09_external_interrupts.pptx
+++ b/slides/lecture09_external_interrupts.pptx
@@ -5,7 +5,7 @@
     <p:sldMasterId id="2147483648" r:id="rId1"/>
   </p:sldMasterIdLst>
   <p:notesMasterIdLst>
-    <p:notesMasterId r:id="rId17"/>
+    <p:notesMasterId r:id="rId18"/>
   </p:notesMasterIdLst>
   <p:sldIdLst>
     <p:sldId id="256" r:id="rId2"/>
@@ -23,6 +23,7 @@
     <p:sldId id="268" r:id="rId14"/>
     <p:sldId id="269" r:id="rId15"/>
     <p:sldId id="270" r:id="rId16"/>
+    <p:sldId id="271" r:id="rId17"/>
   </p:sldIdLst>
   <p:sldSz cx="12192000" cy="6858000"/>
   <p:notesSz cx="6794500" cy="9906000"/>
@@ -141,6 +142,7 @@
             <p14:sldId id="268"/>
             <p14:sldId id="269"/>
             <p14:sldId id="270"/>
+            <p14:sldId id="271"/>
           </p14:sldIdLst>
         </p14:section>
       </p14:sectionLst>
@@ -10068,97 +10070,30 @@
           <a:p>
             <a:r>
               <a:rPr lang="sv-SE"/>
-              <a:t>Kan ett avbrott (t.ex. systick) avbryta sig självt? </a:t>
+              <a:t>Kan ett </a:t>
+            </a:r>
+            <a:r>
+              <a:rPr lang="sv-SE" b="1"/>
+              <a:t>Fault</a:t>
+            </a:r>
+            <a:r>
+              <a:rPr lang="sv-SE"/>
+              <a:t> (t.ex. unaligned memory access) avbryta ett interrupt? </a:t>
             </a:r>
           </a:p>
           <a:p>
             <a:pPr lvl="1"/>
             <a:r>
+              <a:rPr lang="sv-SE"/>
+              <a:t>Yep. Alltid. På så vis kan processorn skyddas mot felaktiga interrupthanterare. </a:t>
+            </a:r>
+          </a:p>
+          <a:p>
+            <a:pPr lvl="1"/>
+            <a:r>
               <a:rPr lang="sv-SE" sz="2000"/>
-              <a:t>Nope. När processorn börjar ta hand om ett avbrott med IRQ </a:t>
-            </a:r>
-            <a:r>
-              <a:rPr lang="sv-SE" sz="2000" i="1"/>
-              <a:t>x</a:t>
-            </a:r>
-            <a:r>
-              <a:rPr lang="sv-SE" sz="2000"/>
-              <a:t> så sätter den bit </a:t>
-            </a:r>
-            <a:r>
-              <a:rPr lang="sv-SE" sz="2000" i="1"/>
-              <a:t>x</a:t>
-            </a:r>
-            <a:r>
-              <a:rPr lang="sv-SE" sz="2000"/>
-              <a:t> i </a:t>
-            </a:r>
-            <a:r>
-              <a:rPr lang="sv-SE" sz="2000" b="1">
-                <a:solidFill>
-                  <a:schemeClr val="accent1">
-                    <a:lumMod val="60000"/>
-                    <a:lumOff val="40000"/>
-                  </a:schemeClr>
-                </a:solidFill>
-              </a:rPr>
-              <a:t>IACTR</a:t>
-            </a:r>
-          </a:p>
-          <a:p>
-            <a:pPr lvl="1"/>
-            <a:r>
-              <a:rPr lang="sv-SE" sz="2000"/>
-              <a:t>Om</a:t>
-            </a:r>
-            <a:r>
-              <a:rPr lang="sv-SE" sz="2000" b="1"/>
-              <a:t> </a:t>
-            </a:r>
-            <a:r>
-              <a:rPr lang="sv-SE" sz="2000"/>
-              <a:t>det kommer ett avbrott till med IRQ x och processorn ser att det aktivt hanteras just nu så sätts istället en bit i </a:t>
-            </a:r>
-            <a:r>
-              <a:rPr lang="sv-SE" sz="2000" b="1">
-                <a:solidFill>
-                  <a:schemeClr val="accent6">
-                    <a:lumMod val="75000"/>
-                  </a:schemeClr>
-                </a:solidFill>
-              </a:rPr>
-              <a:t>IPR</a:t>
-            </a:r>
-          </a:p>
-          <a:p>
-            <a:pPr lvl="1"/>
-            <a:r>
-              <a:rPr lang="sv-SE" sz="2000"/>
-              <a:t>När interupthanteraren returnerar så clearas IACTR, men om IPR är satt sätts den omeddelbart igen och nästa interrupt hanteras direkt.</a:t>
-            </a:r>
-          </a:p>
-          <a:p>
-            <a:pPr lvl="2"/>
-            <a:r>
-              <a:rPr lang="sv-SE" sz="1400"/>
-              <a:t> Om systick interrupts händer för ofta kan huvudprogrammet </a:t>
-            </a:r>
-            <a:r>
-              <a:rPr lang="sv-SE" sz="1400" i="1"/>
-              <a:t>svältas</a:t>
-            </a:r>
-            <a:r>
-              <a:rPr lang="sv-SE" sz="1400"/>
-              <a:t>. </a:t>
-            </a:r>
-          </a:p>
-          <a:p>
-            <a:pPr lvl="2"/>
-            <a:r>
-              <a:rPr lang="sv-SE" sz="1400"/>
-              <a:t>(Om det kommer ett nytt interrupt medans pending biten är satt så ignoreras det)</a:t>
-            </a:r>
-            <a:endParaRPr lang="LID4096" sz="1400"/>
+              <a:t>(mcause, mepc, etc sparas på en hårdvarustack)</a:t>
+            </a:r>
           </a:p>
         </p:txBody>
       </p:sp>
@@ -10197,12 +10132,189 @@
           </a:ln>
         </p:spPr>
       </p:pic>
-      <p:sp>
-        <p:nvSpPr>
-          <p:cNvPr id="8" name="Rectangle 7">
-            <a:extLst>
-              <a:ext uri="{FF2B5EF4-FFF2-40B4-BE49-F238E27FC236}">
-                <a16:creationId xmlns:a16="http://schemas.microsoft.com/office/drawing/2014/main" id="{1812C7E7-7F92-38F8-3072-69452697A141}"/>
+    </p:spTree>
+    <p:extLst>
+      <p:ext uri="{BB962C8B-B14F-4D97-AF65-F5344CB8AC3E}">
+        <p14:creationId xmlns:p14="http://schemas.microsoft.com/office/powerpoint/2010/main" val="3880997693"/>
+      </p:ext>
+    </p:extLst>
+  </p:cSld>
+  <p:clrMapOvr>
+    <a:masterClrMapping/>
+  </p:clrMapOvr>
+</p:sld>
+</file>
+
+<file path=ppt/slides/slide16.xml><?xml version="1.0" encoding="utf-8"?>
+<p:sld xmlns:a="http://schemas.openxmlformats.org/drawingml/2006/main" xmlns:r="http://schemas.openxmlformats.org/officeDocument/2006/relationships" xmlns:p="http://schemas.openxmlformats.org/presentationml/2006/main">
+  <p:cSld>
+    <p:spTree>
+      <p:nvGrpSpPr>
+        <p:cNvPr id="1" name="">
+          <a:extLst>
+            <a:ext uri="{FF2B5EF4-FFF2-40B4-BE49-F238E27FC236}">
+              <a16:creationId xmlns:a16="http://schemas.microsoft.com/office/drawing/2014/main" id="{1EC59E38-39F6-EE93-3F78-FDA822DE0FA9}"/>
+            </a:ext>
+          </a:extLst>
+        </p:cNvPr>
+        <p:cNvGrpSpPr/>
+        <p:nvPr/>
+      </p:nvGrpSpPr>
+      <p:grpSpPr>
+        <a:xfrm>
+          <a:off x="0" y="0"/>
+          <a:ext cx="0" cy="0"/>
+          <a:chOff x="0" y="0"/>
+          <a:chExt cx="0" cy="0"/>
+        </a:xfrm>
+      </p:grpSpPr>
+      <p:sp>
+        <p:nvSpPr>
+          <p:cNvPr id="2" name="Title 1">
+            <a:extLst>
+              <a:ext uri="{FF2B5EF4-FFF2-40B4-BE49-F238E27FC236}">
+                <a16:creationId xmlns:a16="http://schemas.microsoft.com/office/drawing/2014/main" id="{1B414DB9-5CEF-AB60-FC4C-F969F679B6A5}"/>
+              </a:ext>
+            </a:extLst>
+          </p:cNvPr>
+          <p:cNvSpPr>
+            <a:spLocks noGrp="1"/>
+          </p:cNvSpPr>
+          <p:nvPr>
+            <p:ph type="title"/>
+          </p:nvPr>
+        </p:nvSpPr>
+        <p:spPr/>
+        <p:txBody>
+          <a:bodyPr/>
+          <a:lstStyle/>
+          <a:p>
+            <a:r>
+              <a:rPr lang="sv-SE"/>
+              <a:t>Avbryta interrupthanteraren </a:t>
+            </a:r>
+            <a:r>
+              <a:rPr lang="sv-SE" sz="2800"/>
+              <a:t>(nästlade avbrott)</a:t>
+            </a:r>
+            <a:r>
+              <a:rPr lang="sv-SE"/>
+              <a:t>? </a:t>
+            </a:r>
+            <a:endParaRPr lang="LID4096"/>
+          </a:p>
+        </p:txBody>
+      </p:sp>
+      <p:sp>
+        <p:nvSpPr>
+          <p:cNvPr id="7" name="Content Placeholder 6">
+            <a:extLst>
+              <a:ext uri="{FF2B5EF4-FFF2-40B4-BE49-F238E27FC236}">
+                <a16:creationId xmlns:a16="http://schemas.microsoft.com/office/drawing/2014/main" id="{0209B220-B728-CC8E-E36F-F5FB6F5A1479}"/>
+              </a:ext>
+            </a:extLst>
+          </p:cNvPr>
+          <p:cNvSpPr>
+            <a:spLocks noGrp="1"/>
+          </p:cNvSpPr>
+          <p:nvPr>
+            <p:ph idx="1"/>
+          </p:nvPr>
+        </p:nvSpPr>
+        <p:spPr>
+          <a:xfrm>
+            <a:off x="838200" y="1825625"/>
+            <a:ext cx="7067550" cy="4351338"/>
+          </a:xfrm>
+        </p:spPr>
+        <p:txBody>
+          <a:bodyPr/>
+          <a:lstStyle/>
+          <a:p>
+            <a:r>
+              <a:rPr lang="sv-SE"/>
+              <a:t>Kan t.ex. Timer6 avbryta en Systick interrupthanterare? </a:t>
+            </a:r>
+          </a:p>
+          <a:p>
+            <a:pPr lvl="1"/>
+            <a:r>
+              <a:rPr lang="sv-SE"/>
+              <a:t>Ja, </a:t>
+            </a:r>
+            <a:r>
+              <a:rPr lang="sv-SE" i="1"/>
+              <a:t>om</a:t>
+            </a:r>
+            <a:r>
+              <a:rPr lang="sv-SE"/>
+              <a:t> Timer6 har givits högre prioritet än systick i </a:t>
+            </a:r>
+            <a:r>
+              <a:rPr lang="sv-SE" b="1">
+                <a:solidFill>
+                  <a:schemeClr val="accent2">
+                    <a:lumMod val="75000"/>
+                  </a:schemeClr>
+                </a:solidFill>
+              </a:rPr>
+              <a:t>IPRIOR </a:t>
+            </a:r>
+            <a:r>
+              <a:rPr lang="sv-SE"/>
+              <a:t>registrena.</a:t>
+            </a:r>
+          </a:p>
+          <a:p>
+            <a:pPr lvl="1"/>
+            <a:r>
+              <a:rPr lang="sv-SE"/>
+              <a:t>Timer6’s interrupthanterare kör då klart och sedan återupptas Systickhanteraren där den avbröts.</a:t>
+            </a:r>
+          </a:p>
+        </p:txBody>
+      </p:sp>
+      <p:pic>
+        <p:nvPicPr>
+          <p:cNvPr id="5" name="Picture 4">
+            <a:extLst>
+              <a:ext uri="{FF2B5EF4-FFF2-40B4-BE49-F238E27FC236}">
+                <a16:creationId xmlns:a16="http://schemas.microsoft.com/office/drawing/2014/main" id="{FA7585E6-06C4-501A-9E68-68AE76D38AE3}"/>
+              </a:ext>
+            </a:extLst>
+          </p:cNvPr>
+          <p:cNvPicPr>
+            <a:picLocks noChangeAspect="1"/>
+          </p:cNvPicPr>
+          <p:nvPr/>
+        </p:nvPicPr>
+        <p:blipFill>
+          <a:blip r:embed="rId2"/>
+          <a:stretch>
+            <a:fillRect/>
+          </a:stretch>
+        </p:blipFill>
+        <p:spPr>
+          <a:xfrm>
+            <a:off x="8136576" y="1690688"/>
+            <a:ext cx="4055424" cy="5167312"/>
+          </a:xfrm>
+          <a:prstGeom prst="rect">
+            <a:avLst/>
+          </a:prstGeom>
+          <a:ln>
+            <a:solidFill>
+              <a:schemeClr val="tx1"/>
+            </a:solidFill>
+          </a:ln>
+        </p:spPr>
+      </p:pic>
+      <p:sp>
+        <p:nvSpPr>
+          <p:cNvPr id="3" name="Rectangle 2">
+            <a:extLst>
+              <a:ext uri="{FF2B5EF4-FFF2-40B4-BE49-F238E27FC236}">
+                <a16:creationId xmlns:a16="http://schemas.microsoft.com/office/drawing/2014/main" id="{759481A3-902A-D36C-79FE-B1F6DABFC055}"/>
               </a:ext>
             </a:extLst>
           </p:cNvPr>
@@ -10211,75 +10323,14 @@
         </p:nvSpPr>
         <p:spPr>
           <a:xfrm>
-            <a:off x="8198119" y="5938838"/>
+            <a:off x="8200685" y="6281738"/>
             <a:ext cx="3927206" cy="338545"/>
           </a:xfrm>
           <a:prstGeom prst="rect">
             <a:avLst/>
           </a:prstGeom>
           <a:solidFill>
-            <a:schemeClr val="tx2">
-              <a:lumMod val="75000"/>
-              <a:lumOff val="25000"/>
-              <a:alpha val="33000"/>
-            </a:schemeClr>
-          </a:solidFill>
-          <a:ln>
-            <a:solidFill>
-              <a:schemeClr val="tx2">
-                <a:lumMod val="75000"/>
-                <a:lumOff val="25000"/>
-              </a:schemeClr>
-            </a:solidFill>
-          </a:ln>
-        </p:spPr>
-        <p:style>
-          <a:lnRef idx="2">
-            <a:schemeClr val="accent1">
-              <a:shade val="15000"/>
-            </a:schemeClr>
-          </a:lnRef>
-          <a:fillRef idx="1">
-            <a:schemeClr val="accent1"/>
-          </a:fillRef>
-          <a:effectRef idx="0">
-            <a:schemeClr val="accent1"/>
-          </a:effectRef>
-          <a:fontRef idx="minor">
-            <a:schemeClr val="lt1"/>
-          </a:fontRef>
-        </p:style>
-        <p:txBody>
-          <a:bodyPr rtlCol="0" anchor="ctr"/>
-          <a:lstStyle/>
-          <a:p>
-            <a:pPr algn="ctr"/>
-            <a:endParaRPr lang="LID4096"/>
-          </a:p>
-        </p:txBody>
-      </p:sp>
-      <p:sp>
-        <p:nvSpPr>
-          <p:cNvPr id="9" name="Rectangle 8">
-            <a:extLst>
-              <a:ext uri="{FF2B5EF4-FFF2-40B4-BE49-F238E27FC236}">
-                <a16:creationId xmlns:a16="http://schemas.microsoft.com/office/drawing/2014/main" id="{F8A0E4EF-9EC9-7D17-49B4-21AE0E9B34CE}"/>
-              </a:ext>
-            </a:extLst>
-          </p:cNvPr>
-          <p:cNvSpPr/>
-          <p:nvPr/>
-        </p:nvSpPr>
-        <p:spPr>
-          <a:xfrm>
-            <a:off x="8198119" y="2457451"/>
-            <a:ext cx="3927206" cy="338545"/>
-          </a:xfrm>
-          <a:prstGeom prst="rect">
-            <a:avLst/>
-          </a:prstGeom>
-          <a:solidFill>
-            <a:schemeClr val="accent6">
+            <a:schemeClr val="accent2">
               <a:lumMod val="60000"/>
               <a:lumOff val="40000"/>
               <a:alpha val="33000"/>
@@ -10287,7 +10338,7 @@
           </a:solidFill>
           <a:ln>
             <a:solidFill>
-              <a:schemeClr val="accent6">
+              <a:schemeClr val="accent2">
                 <a:lumMod val="75000"/>
               </a:schemeClr>
             </a:solidFill>
@@ -10321,7 +10372,7 @@
     </p:spTree>
     <p:extLst>
       <p:ext uri="{BB962C8B-B14F-4D97-AF65-F5344CB8AC3E}">
-        <p14:creationId xmlns:p14="http://schemas.microsoft.com/office/powerpoint/2010/main" val="3880997693"/>
+        <p14:creationId xmlns:p14="http://schemas.microsoft.com/office/powerpoint/2010/main" val="253192752"/>
       </p:ext>
     </p:extLst>
   </p:cSld>
@@ -10349,7 +10400,7 @@
                             </p:stCondLst>
                             <p:childTnLst>
                               <p:par>
-                                <p:cTn id="5" presetID="10" presetClass="entr" presetSubtype="0" fill="hold" nodeType="clickEffect">
+                                <p:cTn id="5" presetID="10" presetClass="entr" presetSubtype="0" fill="hold" grpId="0" nodeType="clickEffect">
                                   <p:stCondLst>
                                     <p:cond delay="0"/>
                                   </p:stCondLst>
@@ -10362,11 +10413,7 @@
                                           </p:stCondLst>
                                         </p:cTn>
                                         <p:tgtEl>
-                                          <p:spTgt spid="7">
-                                            <p:txEl>
-                                              <p:pRg st="1" end="1"/>
-                                            </p:txEl>
-                                          </p:spTgt>
+                                          <p:spTgt spid="3"/>
                                         </p:tgtEl>
                                         <p:attrNameLst>
                                           <p:attrName>style.visibility</p:attrName>
@@ -10380,361 +10427,7 @@
                                       <p:cBhvr>
                                         <p:cTn id="7" dur="500"/>
                                         <p:tgtEl>
-                                          <p:spTgt spid="7">
-                                            <p:txEl>
-                                              <p:pRg st="1" end="1"/>
-                                            </p:txEl>
-                                          </p:spTgt>
-                                        </p:tgtEl>
-                                      </p:cBhvr>
-                                    </p:animEffect>
-                                  </p:childTnLst>
-                                </p:cTn>
-                              </p:par>
-                            </p:childTnLst>
-                          </p:cTn>
-                        </p:par>
-                      </p:childTnLst>
-                    </p:cTn>
-                  </p:par>
-                  <p:par>
-                    <p:cTn id="8" fill="hold">
-                      <p:stCondLst>
-                        <p:cond delay="indefinite"/>
-                      </p:stCondLst>
-                      <p:childTnLst>
-                        <p:par>
-                          <p:cTn id="9" fill="hold">
-                            <p:stCondLst>
-                              <p:cond delay="0"/>
-                            </p:stCondLst>
-                            <p:childTnLst>
-                              <p:par>
-                                <p:cTn id="10" presetID="10" presetClass="entr" presetSubtype="0" fill="hold" nodeType="clickEffect">
-                                  <p:stCondLst>
-                                    <p:cond delay="0"/>
-                                  </p:stCondLst>
-                                  <p:childTnLst>
-                                    <p:set>
-                                      <p:cBhvr>
-                                        <p:cTn id="11" dur="1" fill="hold">
-                                          <p:stCondLst>
-                                            <p:cond delay="0"/>
-                                          </p:stCondLst>
-                                        </p:cTn>
-                                        <p:tgtEl>
-                                          <p:spTgt spid="7">
-                                            <p:txEl>
-                                              <p:pRg st="2" end="2"/>
-                                            </p:txEl>
-                                          </p:spTgt>
-                                        </p:tgtEl>
-                                        <p:attrNameLst>
-                                          <p:attrName>style.visibility</p:attrName>
-                                        </p:attrNameLst>
-                                      </p:cBhvr>
-                                      <p:to>
-                                        <p:strVal val="visible"/>
-                                      </p:to>
-                                    </p:set>
-                                    <p:animEffect transition="in" filter="fade">
-                                      <p:cBhvr>
-                                        <p:cTn id="12" dur="500"/>
-                                        <p:tgtEl>
-                                          <p:spTgt spid="7">
-                                            <p:txEl>
-                                              <p:pRg st="2" end="2"/>
-                                            </p:txEl>
-                                          </p:spTgt>
-                                        </p:tgtEl>
-                                      </p:cBhvr>
-                                    </p:animEffect>
-                                  </p:childTnLst>
-                                </p:cTn>
-                              </p:par>
-                            </p:childTnLst>
-                          </p:cTn>
-                        </p:par>
-                      </p:childTnLst>
-                    </p:cTn>
-                  </p:par>
-                  <p:par>
-                    <p:cTn id="13" fill="hold">
-                      <p:stCondLst>
-                        <p:cond delay="indefinite"/>
-                      </p:stCondLst>
-                      <p:childTnLst>
-                        <p:par>
-                          <p:cTn id="14" fill="hold">
-                            <p:stCondLst>
-                              <p:cond delay="0"/>
-                            </p:stCondLst>
-                            <p:childTnLst>
-                              <p:par>
-                                <p:cTn id="15" presetID="10" presetClass="entr" presetSubtype="0" fill="hold" nodeType="clickEffect">
-                                  <p:stCondLst>
-                                    <p:cond delay="0"/>
-                                  </p:stCondLst>
-                                  <p:childTnLst>
-                                    <p:set>
-                                      <p:cBhvr>
-                                        <p:cTn id="16" dur="1" fill="hold">
-                                          <p:stCondLst>
-                                            <p:cond delay="0"/>
-                                          </p:stCondLst>
-                                        </p:cTn>
-                                        <p:tgtEl>
-                                          <p:spTgt spid="7">
-                                            <p:txEl>
-                                              <p:pRg st="3" end="3"/>
-                                            </p:txEl>
-                                          </p:spTgt>
-                                        </p:tgtEl>
-                                        <p:attrNameLst>
-                                          <p:attrName>style.visibility</p:attrName>
-                                        </p:attrNameLst>
-                                      </p:cBhvr>
-                                      <p:to>
-                                        <p:strVal val="visible"/>
-                                      </p:to>
-                                    </p:set>
-                                    <p:animEffect transition="in" filter="fade">
-                                      <p:cBhvr>
-                                        <p:cTn id="17" dur="500"/>
-                                        <p:tgtEl>
-                                          <p:spTgt spid="7">
-                                            <p:txEl>
-                                              <p:pRg st="3" end="3"/>
-                                            </p:txEl>
-                                          </p:spTgt>
-                                        </p:tgtEl>
-                                      </p:cBhvr>
-                                    </p:animEffect>
-                                  </p:childTnLst>
-                                </p:cTn>
-                              </p:par>
-                            </p:childTnLst>
-                          </p:cTn>
-                        </p:par>
-                      </p:childTnLst>
-                    </p:cTn>
-                  </p:par>
-                  <p:par>
-                    <p:cTn id="18" fill="hold">
-                      <p:stCondLst>
-                        <p:cond delay="indefinite"/>
-                      </p:stCondLst>
-                      <p:childTnLst>
-                        <p:par>
-                          <p:cTn id="19" fill="hold">
-                            <p:stCondLst>
-                              <p:cond delay="0"/>
-                            </p:stCondLst>
-                            <p:childTnLst>
-                              <p:par>
-                                <p:cTn id="20" presetID="10" presetClass="entr" presetSubtype="0" fill="hold" nodeType="clickEffect">
-                                  <p:stCondLst>
-                                    <p:cond delay="0"/>
-                                  </p:stCondLst>
-                                  <p:childTnLst>
-                                    <p:set>
-                                      <p:cBhvr>
-                                        <p:cTn id="21" dur="1" fill="hold">
-                                          <p:stCondLst>
-                                            <p:cond delay="0"/>
-                                          </p:stCondLst>
-                                        </p:cTn>
-                                        <p:tgtEl>
-                                          <p:spTgt spid="7">
-                                            <p:txEl>
-                                              <p:pRg st="4" end="4"/>
-                                            </p:txEl>
-                                          </p:spTgt>
-                                        </p:tgtEl>
-                                        <p:attrNameLst>
-                                          <p:attrName>style.visibility</p:attrName>
-                                        </p:attrNameLst>
-                                      </p:cBhvr>
-                                      <p:to>
-                                        <p:strVal val="visible"/>
-                                      </p:to>
-                                    </p:set>
-                                    <p:animEffect transition="in" filter="fade">
-                                      <p:cBhvr>
-                                        <p:cTn id="22" dur="500"/>
-                                        <p:tgtEl>
-                                          <p:spTgt spid="7">
-                                            <p:txEl>
-                                              <p:pRg st="4" end="4"/>
-                                            </p:txEl>
-                                          </p:spTgt>
-                                        </p:tgtEl>
-                                      </p:cBhvr>
-                                    </p:animEffect>
-                                  </p:childTnLst>
-                                </p:cTn>
-                              </p:par>
-                            </p:childTnLst>
-                          </p:cTn>
-                        </p:par>
-                      </p:childTnLst>
-                    </p:cTn>
-                  </p:par>
-                  <p:par>
-                    <p:cTn id="23" fill="hold">
-                      <p:stCondLst>
-                        <p:cond delay="indefinite"/>
-                      </p:stCondLst>
-                      <p:childTnLst>
-                        <p:par>
-                          <p:cTn id="24" fill="hold">
-                            <p:stCondLst>
-                              <p:cond delay="0"/>
-                            </p:stCondLst>
-                            <p:childTnLst>
-                              <p:par>
-                                <p:cTn id="25" presetID="10" presetClass="entr" presetSubtype="0" fill="hold" nodeType="clickEffect">
-                                  <p:stCondLst>
-                                    <p:cond delay="0"/>
-                                  </p:stCondLst>
-                                  <p:childTnLst>
-                                    <p:set>
-                                      <p:cBhvr>
-                                        <p:cTn id="26" dur="1" fill="hold">
-                                          <p:stCondLst>
-                                            <p:cond delay="0"/>
-                                          </p:stCondLst>
-                                        </p:cTn>
-                                        <p:tgtEl>
-                                          <p:spTgt spid="7">
-                                            <p:txEl>
-                                              <p:pRg st="5" end="5"/>
-                                            </p:txEl>
-                                          </p:spTgt>
-                                        </p:tgtEl>
-                                        <p:attrNameLst>
-                                          <p:attrName>style.visibility</p:attrName>
-                                        </p:attrNameLst>
-                                      </p:cBhvr>
-                                      <p:to>
-                                        <p:strVal val="visible"/>
-                                      </p:to>
-                                    </p:set>
-                                    <p:animEffect transition="in" filter="fade">
-                                      <p:cBhvr>
-                                        <p:cTn id="27" dur="500"/>
-                                        <p:tgtEl>
-                                          <p:spTgt spid="7">
-                                            <p:txEl>
-                                              <p:pRg st="5" end="5"/>
-                                            </p:txEl>
-                                          </p:spTgt>
-                                        </p:tgtEl>
-                                      </p:cBhvr>
-                                    </p:animEffect>
-                                  </p:childTnLst>
-                                </p:cTn>
-                              </p:par>
-                            </p:childTnLst>
-                          </p:cTn>
-                        </p:par>
-                      </p:childTnLst>
-                    </p:cTn>
-                  </p:par>
-                  <p:par>
-                    <p:cTn id="28" fill="hold">
-                      <p:stCondLst>
-                        <p:cond delay="indefinite"/>
-                      </p:stCondLst>
-                      <p:childTnLst>
-                        <p:par>
-                          <p:cTn id="29" fill="hold">
-                            <p:stCondLst>
-                              <p:cond delay="0"/>
-                            </p:stCondLst>
-                            <p:childTnLst>
-                              <p:par>
-                                <p:cTn id="30" presetID="10" presetClass="entr" presetSubtype="0" fill="hold" grpId="0" nodeType="clickEffect">
-                                  <p:stCondLst>
-                                    <p:cond delay="0"/>
-                                  </p:stCondLst>
-                                  <p:childTnLst>
-                                    <p:set>
-                                      <p:cBhvr>
-                                        <p:cTn id="31" dur="1" fill="hold">
-                                          <p:stCondLst>
-                                            <p:cond delay="0"/>
-                                          </p:stCondLst>
-                                        </p:cTn>
-                                        <p:tgtEl>
-                                          <p:spTgt spid="8"/>
-                                        </p:tgtEl>
-                                        <p:attrNameLst>
-                                          <p:attrName>style.visibility</p:attrName>
-                                        </p:attrNameLst>
-                                      </p:cBhvr>
-                                      <p:to>
-                                        <p:strVal val="visible"/>
-                                      </p:to>
-                                    </p:set>
-                                    <p:animEffect transition="in" filter="fade">
-                                      <p:cBhvr>
-                                        <p:cTn id="32" dur="500"/>
-                                        <p:tgtEl>
-                                          <p:spTgt spid="8"/>
-                                        </p:tgtEl>
-                                      </p:cBhvr>
-                                    </p:animEffect>
-                                  </p:childTnLst>
-                                </p:cTn>
-                              </p:par>
-                            </p:childTnLst>
-                          </p:cTn>
-                        </p:par>
-                      </p:childTnLst>
-                    </p:cTn>
-                  </p:par>
-                  <p:par>
-                    <p:cTn id="33" fill="hold">
-                      <p:stCondLst>
-                        <p:cond delay="indefinite"/>
-                      </p:stCondLst>
-                      <p:childTnLst>
-                        <p:par>
-                          <p:cTn id="34" fill="hold">
-                            <p:stCondLst>
-                              <p:cond delay="0"/>
-                            </p:stCondLst>
-                            <p:childTnLst>
-                              <p:par>
-                                <p:cTn id="35" presetID="10" presetClass="entr" presetSubtype="0" fill="hold" grpId="0" nodeType="clickEffect">
-                                  <p:stCondLst>
-                                    <p:cond delay="0"/>
-                                  </p:stCondLst>
-                                  <p:childTnLst>
-                                    <p:set>
-                                      <p:cBhvr>
-                                        <p:cTn id="36" dur="1" fill="hold">
-                                          <p:stCondLst>
-                                            <p:cond delay="0"/>
-                                          </p:stCondLst>
-                                        </p:cTn>
-                                        <p:tgtEl>
-                                          <p:spTgt spid="9"/>
-                                        </p:tgtEl>
-                                        <p:attrNameLst>
-                                          <p:attrName>style.visibility</p:attrName>
-                                        </p:attrNameLst>
-                                      </p:cBhvr>
-                                      <p:to>
-                                        <p:strVal val="visible"/>
-                                      </p:to>
-                                    </p:set>
-                                    <p:animEffect transition="in" filter="fade">
-                                      <p:cBhvr>
-                                        <p:cTn id="37" dur="500"/>
-                                        <p:tgtEl>
-                                          <p:spTgt spid="9"/>
+                                          <p:spTgt spid="3"/>
                                         </p:tgtEl>
                                       </p:cBhvr>
                                     </p:animEffect>
@@ -10769,8 +10462,7 @@
       </p:par>
     </p:tnLst>
     <p:bldLst>
-      <p:bldP spid="8" grpId="0" animBg="1"/>
-      <p:bldP spid="9" grpId="0" animBg="1"/>
+      <p:bldP spid="3" grpId="0" animBg="1"/>
     </p:bldLst>
   </p:timing>
 </p:sld>

</xml_diff>